<commit_message>
docs(fase1): sincronizar presentacion PPTX con informe Word y modelo operacional
</commit_message>
<xml_diff>
--- a/Borradores/Entrega 1/PRESENTACION_FASE_1_PROYECTO_ACE.pptx
+++ b/Borradores/Entrega 1/PRESENTACION_FASE_1_PROYECTO_ACE.pptx
@@ -4753,7 +4753,7 @@
               </a:defRPr>
             </a:pPr>
             <a:r>
-              <a:t>Ruta Crítica e Hitos Evaluativos Académicos (PTY4614)</a:t>
+              <a:t>Ruta Crítica de 22 Actividades de Ingeniería e Hitos Evaluativos (PTY4614)</a:t>
             </a:r>
           </a:p>
         </p:txBody>
@@ -6976,6 +6976,14 @@
 <file path=ppt/slides/slide13.xml><?xml version="1.0" encoding="utf-8"?>
 <p:sld xmlns:a="http://schemas.openxmlformats.org/drawingml/2006/main" xmlns:p="http://schemas.openxmlformats.org/presentationml/2006/main" xmlns:r="http://schemas.openxmlformats.org/officeDocument/2006/relationships">
   <p:cSld>
+    <p:bg>
+      <p:bgPr>
+        <a:solidFill>
+          <a:srgbClr val="FFFFFF"/>
+        </a:solidFill>
+        <a:effectLst/>
+      </p:bgPr>
+    </p:bg>
     <p:spTree>
       <p:nvGrpSpPr>
         <p:cNvPr id="1" name=""/>
@@ -6992,13 +7000,13 @@
         <p:spPr>
           <a:xfrm>
             <a:off x="731520" y="457200"/>
-            <a:ext cx="10725912" cy="45720"/>
+            <a:ext cx="10728655" cy="45720"/>
           </a:xfrm>
           <a:prstGeom prst="rect">
             <a:avLst/>
           </a:prstGeom>
           <a:solidFill>
-            <a:srgbClr val="003366"/>
+            <a:srgbClr val="2563EB"/>
           </a:solidFill>
           <a:ln>
             <a:noFill/>
@@ -7035,7 +7043,7 @@
         <p:spPr>
           <a:xfrm>
             <a:off x="731520" y="594360"/>
-            <a:ext cx="8412480" cy="822960"/>
+            <a:ext cx="8686800" cy="822960"/>
           </a:xfrm>
           <a:prstGeom prst="rect">
             <a:avLst/>
@@ -7043,32 +7051,37 @@
           <a:noFill/>
         </p:spPr>
         <p:txBody>
-          <a:bodyPr wrap="square">
+          <a:bodyPr wrap="square" lIns="0" tIns="0" rIns="0" bIns="0">
             <a:spAutoFit/>
           </a:bodyPr>
           <a:lstStyle/>
           <a:p>
             <a:pPr>
-              <a:defRPr b="1" sz="2200">
-                <a:solidFill>
-                  <a:srgbClr val="003366"/>
-                </a:solidFill>
-              </a:defRPr>
-            </a:pPr>
-            <a:r>
-              <a:t>Prototipos Visuales de Interfaz (Mockups Figma)</a:t>
-            </a:r>
-          </a:p>
-          <a:p>
-            <a:pPr>
+              <a:defRPr sz="2400" b="1">
+                <a:solidFill>
+                  <a:srgbClr val="1E3A8A"/>
+                </a:solidFill>
+                <a:latin typeface="Arial"/>
+              </a:defRPr>
+            </a:pPr>
+            <a:r>
+              <a:t>Banco de Preguntas Típicas de la Comisión Docente</a:t>
+            </a:r>
+          </a:p>
+          <a:p>
+            <a:pPr>
+              <a:spcBef>
+                <a:spcPts val="200"/>
+              </a:spcBef>
               <a:defRPr sz="1300">
                 <a:solidFill>
-                  <a:srgbClr val="646464"/>
-                </a:solidFill>
-              </a:defRPr>
-            </a:pPr>
-            <a:r>
-              <a:t>Diseño UI/UX del Panel Administrativo Centralizado y Monitoreo de Pantallas</a:t>
+                  <a:srgbClr val="64748B"/>
+                </a:solidFill>
+                <a:latin typeface="Arial"/>
+              </a:defRPr>
+            </a:pPr>
+            <a:r>
+              <a:t>Defensa de Decisiones Técnicas y Metodológicas de Ingeniería</a:t>
             </a:r>
           </a:p>
         </p:txBody>
@@ -7081,18 +7094,18 @@
         </p:nvSpPr>
         <p:spPr>
           <a:xfrm>
-            <a:off x="9144000" y="640080"/>
-            <a:ext cx="2313432" cy="411480"/>
+            <a:off x="9326880" y="640080"/>
+            <a:ext cx="2133295" cy="411480"/>
           </a:xfrm>
           <a:prstGeom prst="roundRect">
             <a:avLst/>
           </a:prstGeom>
           <a:solidFill>
-            <a:srgbClr val="F0F3F6"/>
+            <a:srgbClr val="EEF2FF"/>
           </a:solidFill>
-          <a:ln>
+          <a:ln w="12700">
             <a:solidFill>
-              <a:srgbClr val="C8D2DC"/>
+              <a:srgbClr val="2563EB"/>
             </a:solidFill>
           </a:ln>
         </p:spPr>
@@ -7115,14 +7128,15 @@
           <a:lstStyle/>
           <a:p>
             <a:pPr algn="ctr">
-              <a:defRPr sz="1100" b="1">
-                <a:solidFill>
-                  <a:srgbClr val="003366"/>
-                </a:solidFill>
-              </a:defRPr>
-            </a:pPr>
-            <a:r>
-              <a:t>Paulo Loyola | Bloque 3</a:t>
+              <a:defRPr sz="1050" b="1">
+                <a:solidFill>
+                  <a:srgbClr val="2563EB"/>
+                </a:solidFill>
+                <a:latin typeface="Arial"/>
+              </a:defRPr>
+            </a:pPr>
+            <a:r>
+              <a:t>Todo el Equipo</a:t>
             </a:r>
           </a:p>
         </p:txBody>
@@ -7136,7 +7150,7 @@
         <p:spPr>
           <a:xfrm>
             <a:off x="731520" y="1645920"/>
-            <a:ext cx="3474720" cy="4389120"/>
+            <a:ext cx="5212080" cy="2194560"/>
           </a:xfrm>
           <a:prstGeom prst="roundRect">
             <a:avLst/>
@@ -7144,9 +7158,9 @@
           <a:solidFill>
             <a:srgbClr val="F8FAFC"/>
           </a:solidFill>
-          <a:ln>
+          <a:ln w="12700">
             <a:solidFill>
-              <a:srgbClr val="DAE1E9"/>
+              <a:srgbClr val="E2E8F0"/>
             </a:solidFill>
           </a:ln>
         </p:spPr>
@@ -7165,139 +7179,58 @@
           </a:fontRef>
         </p:style>
         <p:txBody>
-          <a:bodyPr rtlCol="0" anchor="ctr" wrap="square"/>
+          <a:bodyPr rtlCol="0" anchor="t" wrap="square" lIns="228600" rIns="228600" tIns="201168" bIns="182880"/>
           <a:lstStyle/>
           <a:p>
             <a:pPr algn="ctr">
-              <a:defRPr b="1" sz="1300">
-                <a:solidFill>
-                  <a:srgbClr val="003366"/>
-                </a:solidFill>
-              </a:defRPr>
-            </a:pPr>
-            <a:r>
-              <a:t>Componentes de Interfaz UI/UX</a:t>
-            </a:r>
-          </a:p>
-          <a:p>
-            <a:pPr>
-              <a:defRPr b="1" sz="1050">
-                <a:solidFill>
-                  <a:srgbClr val="141E2D"/>
-                </a:solidFill>
-              </a:defRPr>
-            </a:pPr>
-            <a:r>
-              <a:t>• 1. Monitoreo NUC en Vivo</a:t>
-            </a:r>
-          </a:p>
-          <a:p>
-            <a:pPr>
-              <a:defRPr sz="950">
-                <a:solidFill>
-                  <a:srgbClr val="5A646E"/>
-                </a:solidFill>
-              </a:defRPr>
-            </a:pPr>
-            <a:r>
-              <a:t>   Panel de pantallas con semáforo de conectividad (Online / Offline) y última comunicación.</a:t>
-            </a:r>
-          </a:p>
-          <a:p>
-            <a:pPr>
-              <a:defRPr b="1" sz="1050">
-                <a:solidFill>
-                  <a:srgbClr val="141E2D"/>
-                </a:solidFill>
-              </a:defRPr>
-            </a:pPr>
-            <a:r>
-              <a:t>• 2. Catálogo de Medios</a:t>
-            </a:r>
-          </a:p>
-          <a:p>
-            <a:pPr>
-              <a:defRPr sz="950">
-                <a:solidFill>
-                  <a:srgbClr val="5A646E"/>
-                </a:solidFill>
-              </a:defRPr>
-            </a:pPr>
-            <a:r>
-              <a:t>   Carga de videos MP4/imágenes, cálculo SHA-256 automático y metadatos de peso/resolución.</a:t>
-            </a:r>
-          </a:p>
-          <a:p>
-            <a:pPr>
-              <a:defRPr b="1" sz="1050">
-                <a:solidFill>
-                  <a:srgbClr val="141E2D"/>
-                </a:solidFill>
-              </a:defRPr>
-            </a:pPr>
-            <a:r>
-              <a:t>• 3. Parrilla de Horarios</a:t>
-            </a:r>
-          </a:p>
-          <a:p>
-            <a:pPr>
-              <a:defRPr sz="950">
-                <a:solidFill>
-                  <a:srgbClr val="5A646E"/>
-                </a:solidFill>
-              </a:defRPr>
-            </a:pPr>
-            <a:r>
-              <a:t>   Timeline visual para programar listas de reproducción por locación y sector sin solapamientos.</a:t>
-            </a:r>
-          </a:p>
-          <a:p>
-            <a:pPr>
-              <a:defRPr b="1" sz="1050">
-                <a:solidFill>
-                  <a:srgbClr val="141E2D"/>
-                </a:solidFill>
-              </a:defRPr>
-            </a:pPr>
-            <a:r>
-              <a:t>• 4. Vistas por Rol</a:t>
-            </a:r>
-          </a:p>
-          <a:p>
-            <a:pPr>
-              <a:defRPr sz="950">
-                <a:solidFill>
-                  <a:srgbClr val="5A646E"/>
-                </a:solidFill>
-              </a:defRPr>
-            </a:pPr>
-            <a:r>
-              <a:t>   Acceso global para Administrador y vistas restringidas a locaciones asignadas para Operador.</a:t>
-            </a:r>
-          </a:p>
-        </p:txBody>
-      </p:sp>
-      <p:sp>
-        <p:nvSpPr>
-          <p:cNvPr id="6" name="Rounded Rectangle 5"/>
+              <a:spcAft>
+                <a:spcPts val="800"/>
+              </a:spcAft>
+              <a:defRPr sz="1500" b="1">
+                <a:solidFill>
+                  <a:srgbClr val="1E3A8A"/>
+                </a:solidFill>
+                <a:latin typeface="Arial"/>
+              </a:defRPr>
+            </a:pPr>
+            <a:r>
+              <a:t>¿Por qué Laravel y MariaDB vs NoSQL?</a:t>
+            </a:r>
+          </a:p>
+          <a:p>
+            <a:pPr>
+              <a:spcAft>
+                <a:spcPts val="500"/>
+              </a:spcAft>
+              <a:defRPr sz="1100">
+                <a:latin typeface="Arial"/>
+              </a:defRPr>
+            </a:pPr>
+            <a:r>
+              <a:t>Fundamento: El dominio de cartelería digital es estrictamente estructurado (Locaciones &gt; Sectores &gt; Pantallas &gt; Playlists). Las transacciones ACID y llaves foráneas de MariaDB previenen estados inconsistentes y solapamientos que en NoSQL exigirían validaciones manuales complejas.</a:t>
+            </a:r>
+          </a:p>
+        </p:txBody>
+      </p:sp>
+      <p:sp>
+        <p:nvSpPr>
+          <p:cNvPr id="6" name="Rectangle 5"/>
           <p:cNvSpPr/>
           <p:nvPr/>
         </p:nvSpPr>
         <p:spPr>
           <a:xfrm>
-            <a:off x="4389120" y="1645920"/>
-            <a:ext cx="7068312" cy="4389120"/>
-          </a:xfrm>
-          <a:prstGeom prst="roundRect">
+            <a:off x="777240" y="1691640"/>
+            <a:ext cx="5120640" cy="73152"/>
+          </a:xfrm>
+          <a:prstGeom prst="rect">
             <a:avLst/>
           </a:prstGeom>
           <a:solidFill>
-            <a:srgbClr val="F0F4F8"/>
+            <a:srgbClr val="2563EB"/>
           </a:solidFill>
-          <a:ln w="25400">
-            <a:solidFill>
-              <a:srgbClr val="003366"/>
-            </a:solidFill>
+          <a:ln>
+            <a:noFill/>
           </a:ln>
         </p:spPr>
         <p:style>
@@ -7315,39 +7248,378 @@
           </a:fontRef>
         </p:style>
         <p:txBody>
-          <a:bodyPr rtlCol="0" anchor="ctr" wrap="square"/>
+          <a:bodyPr rtlCol="0" anchor="ctr"/>
+          <a:lstStyle/>
+          <a:p>
+            <a:pPr algn="ctr"/>
+          </a:p>
+        </p:txBody>
+      </p:sp>
+      <p:sp>
+        <p:nvSpPr>
+          <p:cNvPr id="7" name="Rounded Rectangle 6"/>
+          <p:cNvSpPr/>
+          <p:nvPr/>
+        </p:nvSpPr>
+        <p:spPr>
+          <a:xfrm>
+            <a:off x="6217920" y="1645920"/>
+            <a:ext cx="5212080" cy="2194560"/>
+          </a:xfrm>
+          <a:prstGeom prst="roundRect">
+            <a:avLst/>
+          </a:prstGeom>
+          <a:solidFill>
+            <a:srgbClr val="F8FAFC"/>
+          </a:solidFill>
+          <a:ln w="12700">
+            <a:solidFill>
+              <a:srgbClr val="E2E8F0"/>
+            </a:solidFill>
+          </a:ln>
+        </p:spPr>
+        <p:style>
+          <a:lnRef idx="1">
+            <a:schemeClr val="accent1"/>
+          </a:lnRef>
+          <a:fillRef idx="3">
+            <a:schemeClr val="accent1"/>
+          </a:fillRef>
+          <a:effectRef idx="2">
+            <a:schemeClr val="accent1"/>
+          </a:effectRef>
+          <a:fontRef idx="minor">
+            <a:schemeClr val="lt1"/>
+          </a:fontRef>
+        </p:style>
+        <p:txBody>
+          <a:bodyPr rtlCol="0" anchor="t" wrap="square" lIns="228600" rIns="228600" tIns="201168" bIns="182880"/>
           <a:lstStyle/>
           <a:p>
             <a:pPr algn="ctr">
-              <a:defRPr b="1" sz="1500">
-                <a:solidFill>
-                  <a:srgbClr val="003366"/>
-                </a:solidFill>
-              </a:defRPr>
-            </a:pPr>
-            <a:br/>
-            <a:br/>
-            <a:br/>
-            <a:r>
-              <a:t>🖼️ [ESPACIO RESERVADO PARA WIREFRAME / MOCKUP DE FIGMA]</a:t>
-            </a:r>
-          </a:p>
+              <a:spcAft>
+                <a:spcPts val="800"/>
+              </a:spcAft>
+              <a:defRPr sz="1500" b="1">
+                <a:solidFill>
+                  <a:srgbClr val="1E3A8A"/>
+                </a:solidFill>
+                <a:latin typeface="Arial"/>
+              </a:defRPr>
+            </a:pPr>
+            <a:r>
+              <a:t>¿Cómo evitan pantallas en negro en malls?</a:t>
+            </a:r>
+          </a:p>
+          <a:p>
+            <a:pPr>
+              <a:spcAft>
+                <a:spcPts val="500"/>
+              </a:spcAft>
+              <a:defRPr sz="1100">
+                <a:latin typeface="Arial"/>
+              </a:defRPr>
+            </a:pPr>
+            <a:r>
+              <a:rPr b="1">
+                <a:solidFill>
+                  <a:srgbClr val="1E3A8A"/>
+                </a:solidFill>
+              </a:rPr>
+              <a:t>Fundamento: </a:t>
+            </a:r>
+            <a:r>
+              <a:rPr>
+                <a:solidFill>
+                  <a:srgbClr val="334155"/>
+                </a:solidFill>
+              </a:rPr>
+              <a:t>Arquitectura Cache-First: el reproductor nunca hace streaming directo. Descarga preventivamente los videos a disco local y verifica SHA-256. Ante caída de red, reproduce localmente y expone un panel web en la intranet para control manual de emergencia.</a:t>
+            </a:r>
+          </a:p>
+        </p:txBody>
+      </p:sp>
+      <p:sp>
+        <p:nvSpPr>
+          <p:cNvPr id="8" name="Rectangle 7"/>
+          <p:cNvSpPr/>
+          <p:nvPr/>
+        </p:nvSpPr>
+        <p:spPr>
+          <a:xfrm>
+            <a:off x="6263640" y="1691640"/>
+            <a:ext cx="5120640" cy="73152"/>
+          </a:xfrm>
+          <a:prstGeom prst="rect">
+            <a:avLst/>
+          </a:prstGeom>
+          <a:solidFill>
+            <a:srgbClr val="0D9488"/>
+          </a:solidFill>
+          <a:ln>
+            <a:noFill/>
+          </a:ln>
+        </p:spPr>
+        <p:style>
+          <a:lnRef idx="1">
+            <a:schemeClr val="accent1"/>
+          </a:lnRef>
+          <a:fillRef idx="3">
+            <a:schemeClr val="accent1"/>
+          </a:fillRef>
+          <a:effectRef idx="2">
+            <a:schemeClr val="accent1"/>
+          </a:effectRef>
+          <a:fontRef idx="minor">
+            <a:schemeClr val="lt1"/>
+          </a:fontRef>
+        </p:style>
+        <p:txBody>
+          <a:bodyPr rtlCol="0" anchor="ctr"/>
+          <a:lstStyle/>
+          <a:p>
+            <a:pPr algn="ctr"/>
+          </a:p>
+        </p:txBody>
+      </p:sp>
+      <p:sp>
+        <p:nvSpPr>
+          <p:cNvPr id="9" name="Rounded Rectangle 8"/>
+          <p:cNvSpPr/>
+          <p:nvPr/>
+        </p:nvSpPr>
+        <p:spPr>
+          <a:xfrm>
+            <a:off x="731520" y="4023360"/>
+            <a:ext cx="5212080" cy="2194560"/>
+          </a:xfrm>
+          <a:prstGeom prst="roundRect">
+            <a:avLst/>
+          </a:prstGeom>
+          <a:solidFill>
+            <a:srgbClr val="F8FAFC"/>
+          </a:solidFill>
+          <a:ln w="12700">
+            <a:solidFill>
+              <a:srgbClr val="E2E8F0"/>
+            </a:solidFill>
+          </a:ln>
+        </p:spPr>
+        <p:style>
+          <a:lnRef idx="1">
+            <a:schemeClr val="accent1"/>
+          </a:lnRef>
+          <a:fillRef idx="3">
+            <a:schemeClr val="accent1"/>
+          </a:fillRef>
+          <a:effectRef idx="2">
+            <a:schemeClr val="accent1"/>
+          </a:effectRef>
+          <a:fontRef idx="minor">
+            <a:schemeClr val="lt1"/>
+          </a:fontRef>
+        </p:style>
+        <p:txBody>
+          <a:bodyPr rtlCol="0" anchor="t" wrap="square" lIns="228600" rIns="228600" tIns="201168" bIns="182880"/>
+          <a:lstStyle/>
           <a:p>
             <a:pPr algn="ctr">
+              <a:spcAft>
+                <a:spcPts val="800"/>
+              </a:spcAft>
+              <a:defRPr sz="1500" b="1">
+                <a:solidFill>
+                  <a:srgbClr val="1E3A8A"/>
+                </a:solidFill>
+                <a:latin typeface="Arial"/>
+              </a:defRPr>
+            </a:pPr>
+            <a:r>
+              <a:t>¿Cómo aseguran terminar en 18 semanas?</a:t>
+            </a:r>
+          </a:p>
+          <a:p>
+            <a:pPr>
+              <a:spcAft>
+                <a:spcPts val="500"/>
+              </a:spcAft>
               <a:defRPr sz="1100">
-                <a:solidFill>
-                  <a:srgbClr val="6E7882"/>
-                </a:solidFill>
-              </a:defRPr>
-            </a:pPr>
-            <a:br/>
-            <a:r>
-              <a:t>Pegue o inserte aquí la captura de pantalla del prototipo de alta fidelidad diseñado en Figma.</a:t>
-            </a:r>
-            <a:br/>
-            <a:r>
-              <a:t>(Panel Web Reactivo Blade • Parrilla de Programación • Telemetría NUC en Vivo)</a:t>
-            </a:r>
+                <a:latin typeface="Arial"/>
+              </a:defRPr>
+            </a:pPr>
+            <a:r>
+              <a:rPr b="1">
+                <a:solidFill>
+                  <a:srgbClr val="1E3A8A"/>
+                </a:solidFill>
+              </a:rPr>
+              <a:t>Fundamento: </a:t>
+            </a:r>
+            <a:r>
+              <a:rPr>
+                <a:solidFill>
+                  <a:srgbClr val="334155"/>
+                </a:solidFill>
+              </a:rPr>
+              <a:t>Delimitación estricta del alcance: ACE es distribución y programación (se excluye edición de video). Scrum bisemanal con hito crítico en S10 (core API y DB operativo), dejando semanas finales para pruebas de resiliencia y UAT con Lumina.</a:t>
+            </a:r>
+          </a:p>
+        </p:txBody>
+      </p:sp>
+      <p:sp>
+        <p:nvSpPr>
+          <p:cNvPr id="10" name="Rectangle 9"/>
+          <p:cNvSpPr/>
+          <p:nvPr/>
+        </p:nvSpPr>
+        <p:spPr>
+          <a:xfrm>
+            <a:off x="777240" y="4069080"/>
+            <a:ext cx="5120640" cy="73152"/>
+          </a:xfrm>
+          <a:prstGeom prst="rect">
+            <a:avLst/>
+          </a:prstGeom>
+          <a:solidFill>
+            <a:srgbClr val="D97706"/>
+          </a:solidFill>
+          <a:ln>
+            <a:noFill/>
+          </a:ln>
+        </p:spPr>
+        <p:style>
+          <a:lnRef idx="1">
+            <a:schemeClr val="accent1"/>
+          </a:lnRef>
+          <a:fillRef idx="3">
+            <a:schemeClr val="accent1"/>
+          </a:fillRef>
+          <a:effectRef idx="2">
+            <a:schemeClr val="accent1"/>
+          </a:effectRef>
+          <a:fontRef idx="minor">
+            <a:schemeClr val="lt1"/>
+          </a:fontRef>
+        </p:style>
+        <p:txBody>
+          <a:bodyPr rtlCol="0" anchor="ctr"/>
+          <a:lstStyle/>
+          <a:p>
+            <a:pPr algn="ctr"/>
+          </a:p>
+        </p:txBody>
+      </p:sp>
+      <p:sp>
+        <p:nvSpPr>
+          <p:cNvPr id="11" name="Rounded Rectangle 10"/>
+          <p:cNvSpPr/>
+          <p:nvPr/>
+        </p:nvSpPr>
+        <p:spPr>
+          <a:xfrm>
+            <a:off x="6217920" y="4023360"/>
+            <a:ext cx="5212080" cy="2194560"/>
+          </a:xfrm>
+          <a:prstGeom prst="roundRect">
+            <a:avLst/>
+          </a:prstGeom>
+          <a:solidFill>
+            <a:srgbClr val="F8FAFC"/>
+          </a:solidFill>
+          <a:ln w="12700">
+            <a:solidFill>
+              <a:srgbClr val="E2E8F0"/>
+            </a:solidFill>
+          </a:ln>
+        </p:spPr>
+        <p:style>
+          <a:lnRef idx="1">
+            <a:schemeClr val="accent1"/>
+          </a:lnRef>
+          <a:fillRef idx="3">
+            <a:schemeClr val="accent1"/>
+          </a:fillRef>
+          <a:effectRef idx="2">
+            <a:schemeClr val="accent1"/>
+          </a:effectRef>
+          <a:fontRef idx="minor">
+            <a:schemeClr val="lt1"/>
+          </a:fontRef>
+        </p:style>
+        <p:txBody>
+          <a:bodyPr rtlCol="0" anchor="t" wrap="square" lIns="228600" rIns="228600" tIns="201168" bIns="182880"/>
+          <a:lstStyle/>
+          <a:p>
+            <a:pPr algn="ctr">
+              <a:spcAft>
+                <a:spcPts val="800"/>
+              </a:spcAft>
+              <a:defRPr sz="1500" b="1">
+                <a:solidFill>
+                  <a:srgbClr val="1E3A8A"/>
+                </a:solidFill>
+                <a:latin typeface="Arial"/>
+              </a:defRPr>
+            </a:pPr>
+            <a:r>
+              <a:t>¿Cómo garantizan aporte equitativo?</a:t>
+            </a:r>
+          </a:p>
+          <a:p>
+            <a:pPr>
+              <a:spcAft>
+                <a:spcPts val="500"/>
+              </a:spcAft>
+              <a:defRPr sz="1100">
+                <a:latin typeface="Arial"/>
+              </a:defRPr>
+            </a:pPr>
+            <a:r>
+              <a:t>Fundamento: Distribución por dominios técnicos complementarios y corresponsabilidad en persistencia (MariaDB): Tomás (Arquitectura, Backend y BD), Matías (Gestión Ágil, Vinculación con Cliente y BD) y Paulo (Frontend, UI/UX y Documentación Técnica). Trazabilidad auditable mediante Pull Requests cruzados en GitHub.</a:t>
+            </a:r>
+          </a:p>
+        </p:txBody>
+      </p:sp>
+      <p:sp>
+        <p:nvSpPr>
+          <p:cNvPr id="12" name="Rectangle 11"/>
+          <p:cNvSpPr/>
+          <p:nvPr/>
+        </p:nvSpPr>
+        <p:spPr>
+          <a:xfrm>
+            <a:off x="6263640" y="4069080"/>
+            <a:ext cx="5120640" cy="73152"/>
+          </a:xfrm>
+          <a:prstGeom prst="rect">
+            <a:avLst/>
+          </a:prstGeom>
+          <a:solidFill>
+            <a:srgbClr val="1E3A8A"/>
+          </a:solidFill>
+          <a:ln>
+            <a:noFill/>
+          </a:ln>
+        </p:spPr>
+        <p:style>
+          <a:lnRef idx="1">
+            <a:schemeClr val="accent1"/>
+          </a:lnRef>
+          <a:fillRef idx="3">
+            <a:schemeClr val="accent1"/>
+          </a:fillRef>
+          <a:effectRef idx="2">
+            <a:schemeClr val="accent1"/>
+          </a:effectRef>
+          <a:fontRef idx="minor">
+            <a:schemeClr val="lt1"/>
+          </a:fontRef>
+        </p:style>
+        <p:txBody>
+          <a:bodyPr rtlCol="0" anchor="ctr"/>
+          <a:lstStyle/>
+          <a:p>
+            <a:pPr algn="ctr"/>
           </a:p>
         </p:txBody>
       </p:sp>
@@ -9230,20 +9502,7 @@
               </a:defRPr>
             </a:pPr>
             <a:r>
-              <a:rPr b="1">
-                <a:solidFill>
-                  <a:srgbClr val="1E3A8A"/>
-                </a:solidFill>
-              </a:rPr>
-              <a:t>Panel Local de Emergencia: </a:t>
-            </a:r>
-            <a:r>
-              <a:rPr>
-                <a:solidFill>
-                  <a:srgbClr val="334155"/>
-                </a:solidFill>
-              </a:rPr>
-              <a:t>Servidor web embebido en la intranet para conmutación manual presencial.</a:t>
+              <a:t>Modificación Local sin Internet: Panel local en el nodo reproductor NUC para conmutación manual presencial ante contingencias.</a:t>
             </a:r>
           </a:p>
         </p:txBody>
@@ -10657,7 +10916,7 @@
               </a:defRPr>
             </a:pPr>
             <a:r>
-              <a:t>Vinculación con el Cliente y Matriz de Riesgos</a:t>
+              <a:t>Factibilidad, Matriz de Riesgos y Modelo Operacional</a:t>
             </a:r>
           </a:p>
           <a:p>
@@ -10673,7 +10932,7 @@
               </a:defRPr>
             </a:pPr>
             <a:r>
-              <a:t>Factibilidad en 18 Semanas y Mitigación Estratégica</a:t>
+              <a:t>Viabilidad en 18 Semanas, Mitigación de Contingencias e Impacto en Lumina Motion</a:t>
             </a:r>
           </a:p>
         </p:txBody>
@@ -10778,145 +11037,55 @@
               <a:spcAft>
                 <a:spcPts val="800"/>
               </a:spcAft>
-              <a:defRPr sz="1500" b="1">
-                <a:solidFill>
-                  <a:srgbClr val="1E3A8A"/>
-                </a:solidFill>
-                <a:latin typeface="Arial"/>
-              </a:defRPr>
-            </a:pPr>
-            <a:r>
-              <a:t>Relación Técnica con Lumina Motion</a:t>
-            </a:r>
-          </a:p>
-          <a:p>
-            <a:pPr>
-              <a:spcAft>
-                <a:spcPts val="500"/>
-              </a:spcAft>
-              <a:defRPr sz="1100">
-                <a:latin typeface="Arial"/>
-              </a:defRPr>
-            </a:pPr>
-            <a:r>
-              <a:rPr b="1">
-                <a:solidFill>
-                  <a:srgbClr val="1E3A8A"/>
-                </a:solidFill>
-              </a:rPr>
-              <a:t>Interlocutor Clave: </a:t>
-            </a:r>
-            <a:r>
-              <a:rPr>
-                <a:solidFill>
-                  <a:srgbClr val="334155"/>
-                </a:solidFill>
-              </a:rPr>
-              <a:t>Cristóbal Manzo, Jefe de Informática en Lumina Motion Studio.</a:t>
-            </a:r>
-          </a:p>
-          <a:p>
-            <a:pPr>
-              <a:spcAft>
-                <a:spcPts val="500"/>
-              </a:spcAft>
-              <a:defRPr sz="1100">
-                <a:latin typeface="Arial"/>
-              </a:defRPr>
-            </a:pPr>
-            <a:r>
-              <a:rPr b="1">
-                <a:solidFill>
-                  <a:srgbClr val="1E3A8A"/>
-                </a:solidFill>
-              </a:rPr>
-              <a:t>Acceso Directo: </a:t>
-            </a:r>
-            <a:r>
-              <a:rPr>
-                <a:solidFill>
-                  <a:srgbClr val="334155"/>
-                </a:solidFill>
-              </a:rPr>
-              <a:t>Reuniones periódicas para levantamiento de requisitos funcionales y diseño de pautas.</a:t>
-            </a:r>
-          </a:p>
-          <a:p>
-            <a:pPr>
-              <a:spcAft>
-                <a:spcPts val="500"/>
-              </a:spcAft>
-              <a:defRPr sz="1100">
-                <a:latin typeface="Arial"/>
-              </a:defRPr>
-            </a:pPr>
-            <a:r>
-              <a:rPr b="1">
-                <a:solidFill>
-                  <a:srgbClr val="1E3A8A"/>
-                </a:solidFill>
-              </a:rPr>
-              <a:t>Validación en Terreno: </a:t>
-            </a:r>
-            <a:r>
-              <a:rPr>
-                <a:solidFill>
-                  <a:srgbClr val="334155"/>
-                </a:solidFill>
-              </a:rPr>
-              <a:t>Pruebas UAT sobre infraestructura visual real instalada en centros comerciales.</a:t>
-            </a:r>
-          </a:p>
-          <a:p>
-            <a:pPr>
-              <a:spcAft>
-                <a:spcPts val="500"/>
-              </a:spcAft>
-              <a:defRPr sz="1100">
-                <a:latin typeface="Arial"/>
-              </a:defRPr>
-            </a:pPr>
-            <a:r>
-              <a:rPr b="1">
-                <a:solidFill>
-                  <a:srgbClr val="1E3A8A"/>
-                </a:solidFill>
-              </a:rPr>
-              <a:t>Viabilidad 18 Semanas: </a:t>
-            </a:r>
-            <a:r>
-              <a:rPr>
-                <a:solidFill>
-                  <a:srgbClr val="334155"/>
-                </a:solidFill>
-              </a:rPr>
-              <a:t>Alcance estrictamente delimitado: plataforma de distribución y gestión (sin edición de video).</a:t>
-            </a:r>
-          </a:p>
-          <a:p>
-            <a:pPr>
-              <a:spcAft>
-                <a:spcPts val="500"/>
-              </a:spcAft>
-              <a:defRPr sz="1100">
-                <a:latin typeface="Arial"/>
-              </a:defRPr>
-            </a:pPr>
-            <a:r>
-              <a:rPr b="1">
-                <a:solidFill>
-                  <a:srgbClr val="1E3A8A"/>
-                </a:solidFill>
-              </a:rPr>
-              <a:t>Infraestructura: </a:t>
-            </a:r>
-            <a:r>
-              <a:rPr>
-                <a:solidFill>
-                  <a:srgbClr val="334155"/>
-                </a:solidFill>
-              </a:rPr>
-              <a:t>Disponibilidad de microcomputadores Mini-PC, switches de red y monitores de prueba.</a:t>
+              <a:defRPr sz="1400" b="1">
+                <a:solidFill>
+                  <a:srgbClr val="003366"/>
+                </a:solidFill>
+                <a:latin typeface="Arial"/>
+              </a:defRPr>
+            </a:pPr>
+            <a:r>
+              <a:t>Relación con Lumina y Modelo Operacional</a:t>
+            </a:r>
+          </a:p>
+          <a:p>
+            <a:pPr>
+              <a:defRPr sz="1050"/>
+            </a:pPr>
+            <a:r>
+              <a:t>• Interlocutor Clave: Cristóbal Manzo, Jefe de Informática en Lumina Motion Studio.</a:t>
+            </a:r>
+          </a:p>
+          <a:p>
+            <a:pPr>
+              <a:defRPr sz="1050"/>
+            </a:pPr>
+            <a:r>
+              <a:t>• Acceso y Validación: Reuniones periódicas de levantamiento funcional y pruebas UAT sobre pantallas reales.</a:t>
+            </a:r>
+          </a:p>
+          <a:p>
+            <a:pPr>
+              <a:defRPr sz="1050"/>
+            </a:pPr>
+            <a:r>
+              <a:t>• Modelo Internal Tooling: Software a medida para operación interna; sustituye licencias comerciales de MadMapper/Arena.im.</a:t>
+            </a:r>
+          </a:p>
+          <a:p>
+            <a:pPr>
+              <a:defRPr sz="1050"/>
+            </a:pPr>
+            <a:r>
+              <a:t>• Impacto Financiero: Reduce a cero los viáticos y traslados técnicos in situ para actualizaciones de anuncios por USB.</a:t>
+            </a:r>
+          </a:p>
+          <a:p>
+            <a:pPr>
+              <a:defRPr sz="1050"/>
+            </a:pPr>
+            <a:r>
+              <a:t>• Viabilidad 18 Semanas: Alcance estrictamente delimitado a distribución, programación y resiliencia (sin edición audiovisual).</a:t>
             </a:r>
           </a:p>
         </p:txBody>
@@ -11694,20 +11863,7 @@
               </a:defRPr>
             </a:pPr>
             <a:r>
-              <a:rPr b="1">
-                <a:solidFill>
-                  <a:srgbClr val="1E3A8A"/>
-                </a:solidFill>
-              </a:rPr>
-              <a:t>Panel Local de Emergencia: </a:t>
-            </a:r>
-            <a:r>
-              <a:rPr>
-                <a:solidFill>
-                  <a:srgbClr val="334155"/>
-                </a:solidFill>
-              </a:rPr>
-              <a:t>Interfaz web embebida en el nodo de sitio para control manual in situ sin internet.</a:t>
+              <a:t>Modificación Local sin Internet: Panel embebido en nodo NUC para conmutación manual in situ ante contingencias.</a:t>
             </a:r>
           </a:p>
         </p:txBody>
@@ -11766,14 +11922,6 @@
 <file path=ppt/slides/slide9.xml><?xml version="1.0" encoding="utf-8"?>
 <p:sld xmlns:a="http://schemas.openxmlformats.org/drawingml/2006/main" xmlns:p="http://schemas.openxmlformats.org/presentationml/2006/main" xmlns:r="http://schemas.openxmlformats.org/officeDocument/2006/relationships">
   <p:cSld>
-    <p:bg>
-      <p:bgPr>
-        <a:solidFill>
-          <a:srgbClr val="FFFFFF"/>
-        </a:solidFill>
-        <a:effectLst/>
-      </p:bgPr>
-    </p:bg>
     <p:spTree>
       <p:nvGrpSpPr>
         <p:cNvPr id="1" name=""/>
@@ -11790,13 +11938,13 @@
         <p:spPr>
           <a:xfrm>
             <a:off x="731520" y="457200"/>
-            <a:ext cx="10728655" cy="45720"/>
+            <a:ext cx="10725912" cy="45720"/>
           </a:xfrm>
           <a:prstGeom prst="rect">
             <a:avLst/>
           </a:prstGeom>
           <a:solidFill>
-            <a:srgbClr val="2563EB"/>
+            <a:srgbClr val="003366"/>
           </a:solidFill>
           <a:ln>
             <a:noFill/>
@@ -11833,7 +11981,7 @@
         <p:spPr>
           <a:xfrm>
             <a:off x="731520" y="594360"/>
-            <a:ext cx="8686800" cy="822960"/>
+            <a:ext cx="8412480" cy="822960"/>
           </a:xfrm>
           <a:prstGeom prst="rect">
             <a:avLst/>
@@ -11841,37 +11989,32 @@
           <a:noFill/>
         </p:spPr>
         <p:txBody>
-          <a:bodyPr wrap="square" lIns="0" tIns="0" rIns="0" bIns="0">
+          <a:bodyPr wrap="square">
             <a:spAutoFit/>
           </a:bodyPr>
           <a:lstStyle/>
           <a:p>
             <a:pPr>
-              <a:defRPr sz="2400" b="1">
-                <a:solidFill>
-                  <a:srgbClr val="1E3A8A"/>
-                </a:solidFill>
-                <a:latin typeface="Arial"/>
-              </a:defRPr>
-            </a:pPr>
-            <a:r>
-              <a:t>Banco de Preguntas Típicas de la Comisión Docente</a:t>
-            </a:r>
-          </a:p>
-          <a:p>
-            <a:pPr>
-              <a:spcBef>
-                <a:spcPts val="200"/>
-              </a:spcBef>
+              <a:defRPr b="1" sz="2200">
+                <a:solidFill>
+                  <a:srgbClr val="003366"/>
+                </a:solidFill>
+              </a:defRPr>
+            </a:pPr>
+            <a:r>
+              <a:t>Prototipos Visuales de Interfaz (Mockups Figma)</a:t>
+            </a:r>
+          </a:p>
+          <a:p>
+            <a:pPr>
               <a:defRPr sz="1300">
                 <a:solidFill>
-                  <a:srgbClr val="64748B"/>
-                </a:solidFill>
-                <a:latin typeface="Arial"/>
-              </a:defRPr>
-            </a:pPr>
-            <a:r>
-              <a:t>Defensa de Decisiones Técnicas y Metodológicas de Ingeniería</a:t>
+                  <a:srgbClr val="646464"/>
+                </a:solidFill>
+              </a:defRPr>
+            </a:pPr>
+            <a:r>
+              <a:t>Diseño UI/UX del Panel Administrativo Centralizado y Monitoreo de Pantallas</a:t>
             </a:r>
           </a:p>
         </p:txBody>
@@ -11884,18 +12027,18 @@
         </p:nvSpPr>
         <p:spPr>
           <a:xfrm>
-            <a:off x="9326880" y="640080"/>
-            <a:ext cx="2133295" cy="411480"/>
+            <a:off x="9144000" y="640080"/>
+            <a:ext cx="2313432" cy="411480"/>
           </a:xfrm>
           <a:prstGeom prst="roundRect">
             <a:avLst/>
           </a:prstGeom>
           <a:solidFill>
-            <a:srgbClr val="EEF2FF"/>
+            <a:srgbClr val="F0F3F6"/>
           </a:solidFill>
-          <a:ln w="12700">
+          <a:ln>
             <a:solidFill>
-              <a:srgbClr val="2563EB"/>
+              <a:srgbClr val="C8D2DC"/>
             </a:solidFill>
           </a:ln>
         </p:spPr>
@@ -11918,15 +12061,14 @@
           <a:lstStyle/>
           <a:p>
             <a:pPr algn="ctr">
-              <a:defRPr sz="1050" b="1">
-                <a:solidFill>
-                  <a:srgbClr val="2563EB"/>
-                </a:solidFill>
-                <a:latin typeface="Arial"/>
-              </a:defRPr>
-            </a:pPr>
-            <a:r>
-              <a:t>Todo el Equipo</a:t>
+              <a:defRPr sz="1100" b="1">
+                <a:solidFill>
+                  <a:srgbClr val="003366"/>
+                </a:solidFill>
+              </a:defRPr>
+            </a:pPr>
+            <a:r>
+              <a:t>Paulo Loyola | Bloque 3</a:t>
             </a:r>
           </a:p>
         </p:txBody>
@@ -11940,7 +12082,7 @@
         <p:spPr>
           <a:xfrm>
             <a:off x="731520" y="1645920"/>
-            <a:ext cx="5212080" cy="2194560"/>
+            <a:ext cx="3474720" cy="4389120"/>
           </a:xfrm>
           <a:prstGeom prst="roundRect">
             <a:avLst/>
@@ -11948,9 +12090,9 @@
           <a:solidFill>
             <a:srgbClr val="F8FAFC"/>
           </a:solidFill>
-          <a:ln w="12700">
+          <a:ln>
             <a:solidFill>
-              <a:srgbClr val="E2E8F0"/>
+              <a:srgbClr val="DAE1E9"/>
             </a:solidFill>
           </a:ln>
         </p:spPr>
@@ -11969,58 +12111,139 @@
           </a:fontRef>
         </p:style>
         <p:txBody>
-          <a:bodyPr rtlCol="0" anchor="t" wrap="square" lIns="228600" rIns="228600" tIns="201168" bIns="182880"/>
+          <a:bodyPr rtlCol="0" anchor="ctr" wrap="square"/>
           <a:lstStyle/>
           <a:p>
             <a:pPr algn="ctr">
-              <a:spcAft>
-                <a:spcPts val="800"/>
-              </a:spcAft>
-              <a:defRPr sz="1500" b="1">
-                <a:solidFill>
-                  <a:srgbClr val="1E3A8A"/>
-                </a:solidFill>
-                <a:latin typeface="Arial"/>
-              </a:defRPr>
-            </a:pPr>
-            <a:r>
-              <a:t>¿Por qué Laravel y MariaDB vs NoSQL?</a:t>
-            </a:r>
-          </a:p>
-          <a:p>
-            <a:pPr>
-              <a:spcAft>
-                <a:spcPts val="500"/>
-              </a:spcAft>
-              <a:defRPr sz="1100">
-                <a:latin typeface="Arial"/>
-              </a:defRPr>
-            </a:pPr>
-            <a:r>
-              <a:t>Fundamento: El dominio de cartelería digital es estrictamente estructurado (Locaciones &gt; Sectores &gt; Pantallas &gt; Playlists). Las transacciones ACID y llaves foráneas de MariaDB previenen estados inconsistentes y solapamientos que en NoSQL exigirían validaciones manuales complejas.</a:t>
-            </a:r>
-          </a:p>
-        </p:txBody>
-      </p:sp>
-      <p:sp>
-        <p:nvSpPr>
-          <p:cNvPr id="6" name="Rectangle 5"/>
+              <a:defRPr b="1" sz="1300">
+                <a:solidFill>
+                  <a:srgbClr val="003366"/>
+                </a:solidFill>
+              </a:defRPr>
+            </a:pPr>
+            <a:r>
+              <a:t>Componentes de Interfaz UI/UX</a:t>
+            </a:r>
+          </a:p>
+          <a:p>
+            <a:pPr>
+              <a:defRPr b="1" sz="1050">
+                <a:solidFill>
+                  <a:srgbClr val="141E2D"/>
+                </a:solidFill>
+              </a:defRPr>
+            </a:pPr>
+            <a:r>
+              <a:t>• 1. Monitoreo NUC en Vivo</a:t>
+            </a:r>
+          </a:p>
+          <a:p>
+            <a:pPr>
+              <a:defRPr sz="950">
+                <a:solidFill>
+                  <a:srgbClr val="5A646E"/>
+                </a:solidFill>
+              </a:defRPr>
+            </a:pPr>
+            <a:r>
+              <a:t>   Panel de pantallas con semáforo de conectividad (Online / Offline) y última comunicación.</a:t>
+            </a:r>
+          </a:p>
+          <a:p>
+            <a:pPr>
+              <a:defRPr b="1" sz="1050">
+                <a:solidFill>
+                  <a:srgbClr val="141E2D"/>
+                </a:solidFill>
+              </a:defRPr>
+            </a:pPr>
+            <a:r>
+              <a:t>• 2. Catálogo de Medios</a:t>
+            </a:r>
+          </a:p>
+          <a:p>
+            <a:pPr>
+              <a:defRPr sz="950">
+                <a:solidFill>
+                  <a:srgbClr val="5A646E"/>
+                </a:solidFill>
+              </a:defRPr>
+            </a:pPr>
+            <a:r>
+              <a:t>   Carga de videos MP4/imágenes, cálculo SHA-256 automático y metadatos de peso/resolución.</a:t>
+            </a:r>
+          </a:p>
+          <a:p>
+            <a:pPr>
+              <a:defRPr b="1" sz="1050">
+                <a:solidFill>
+                  <a:srgbClr val="141E2D"/>
+                </a:solidFill>
+              </a:defRPr>
+            </a:pPr>
+            <a:r>
+              <a:t>• 3. Parrilla de Horarios</a:t>
+            </a:r>
+          </a:p>
+          <a:p>
+            <a:pPr>
+              <a:defRPr sz="950">
+                <a:solidFill>
+                  <a:srgbClr val="5A646E"/>
+                </a:solidFill>
+              </a:defRPr>
+            </a:pPr>
+            <a:r>
+              <a:t>   Timeline visual para programar listas de reproducción por locación y sector sin solapamientos.</a:t>
+            </a:r>
+          </a:p>
+          <a:p>
+            <a:pPr>
+              <a:defRPr b="1" sz="1050">
+                <a:solidFill>
+                  <a:srgbClr val="141E2D"/>
+                </a:solidFill>
+              </a:defRPr>
+            </a:pPr>
+            <a:r>
+              <a:t>• 4. Vistas por Rol</a:t>
+            </a:r>
+          </a:p>
+          <a:p>
+            <a:pPr>
+              <a:defRPr sz="950">
+                <a:solidFill>
+                  <a:srgbClr val="5A646E"/>
+                </a:solidFill>
+              </a:defRPr>
+            </a:pPr>
+            <a:r>
+              <a:t>   Acceso global para Administrador y vistas restringidas a locaciones asignadas para Operador.</a:t>
+            </a:r>
+          </a:p>
+        </p:txBody>
+      </p:sp>
+      <p:sp>
+        <p:nvSpPr>
+          <p:cNvPr id="6" name="Rounded Rectangle 5"/>
           <p:cNvSpPr/>
           <p:nvPr/>
         </p:nvSpPr>
         <p:spPr>
           <a:xfrm>
-            <a:off x="777240" y="1691640"/>
-            <a:ext cx="5120640" cy="73152"/>
-          </a:xfrm>
-          <a:prstGeom prst="rect">
+            <a:off x="4389120" y="1645920"/>
+            <a:ext cx="7068312" cy="4389120"/>
+          </a:xfrm>
+          <a:prstGeom prst="roundRect">
             <a:avLst/>
           </a:prstGeom>
           <a:solidFill>
-            <a:srgbClr val="2563EB"/>
+            <a:srgbClr val="F0F4F8"/>
           </a:solidFill>
-          <a:ln>
-            <a:noFill/>
+          <a:ln w="25400">
+            <a:solidFill>
+              <a:srgbClr val="003366"/>
+            </a:solidFill>
           </a:ln>
         </p:spPr>
         <p:style>
@@ -12038,378 +12261,39 @@
           </a:fontRef>
         </p:style>
         <p:txBody>
-          <a:bodyPr rtlCol="0" anchor="ctr"/>
-          <a:lstStyle/>
-          <a:p>
-            <a:pPr algn="ctr"/>
-          </a:p>
-        </p:txBody>
-      </p:sp>
-      <p:sp>
-        <p:nvSpPr>
-          <p:cNvPr id="7" name="Rounded Rectangle 6"/>
-          <p:cNvSpPr/>
-          <p:nvPr/>
-        </p:nvSpPr>
-        <p:spPr>
-          <a:xfrm>
-            <a:off x="6217920" y="1645920"/>
-            <a:ext cx="5212080" cy="2194560"/>
-          </a:xfrm>
-          <a:prstGeom prst="roundRect">
-            <a:avLst/>
-          </a:prstGeom>
-          <a:solidFill>
-            <a:srgbClr val="F8FAFC"/>
-          </a:solidFill>
-          <a:ln w="12700">
-            <a:solidFill>
-              <a:srgbClr val="E2E8F0"/>
-            </a:solidFill>
-          </a:ln>
-        </p:spPr>
-        <p:style>
-          <a:lnRef idx="1">
-            <a:schemeClr val="accent1"/>
-          </a:lnRef>
-          <a:fillRef idx="3">
-            <a:schemeClr val="accent1"/>
-          </a:fillRef>
-          <a:effectRef idx="2">
-            <a:schemeClr val="accent1"/>
-          </a:effectRef>
-          <a:fontRef idx="minor">
-            <a:schemeClr val="lt1"/>
-          </a:fontRef>
-        </p:style>
-        <p:txBody>
-          <a:bodyPr rtlCol="0" anchor="t" wrap="square" lIns="228600" rIns="228600" tIns="201168" bIns="182880"/>
+          <a:bodyPr rtlCol="0" anchor="ctr" wrap="square"/>
           <a:lstStyle/>
           <a:p>
             <a:pPr algn="ctr">
-              <a:spcAft>
-                <a:spcPts val="800"/>
-              </a:spcAft>
-              <a:defRPr sz="1500" b="1">
-                <a:solidFill>
-                  <a:srgbClr val="1E3A8A"/>
-                </a:solidFill>
-                <a:latin typeface="Arial"/>
-              </a:defRPr>
-            </a:pPr>
-            <a:r>
-              <a:t>¿Cómo evitan pantallas en negro en malls?</a:t>
-            </a:r>
-          </a:p>
-          <a:p>
-            <a:pPr>
-              <a:spcAft>
-                <a:spcPts val="500"/>
-              </a:spcAft>
+              <a:defRPr b="1" sz="1500">
+                <a:solidFill>
+                  <a:srgbClr val="003366"/>
+                </a:solidFill>
+              </a:defRPr>
+            </a:pPr>
+            <a:br/>
+            <a:br/>
+            <a:br/>
+            <a:r>
+              <a:t>🖼️ [ESPACIO RESERVADO PARA WIREFRAME / MOCKUP DE FIGMA]</a:t>
+            </a:r>
+          </a:p>
+          <a:p>
+            <a:pPr algn="ctr">
               <a:defRPr sz="1100">
-                <a:latin typeface="Arial"/>
-              </a:defRPr>
-            </a:pPr>
-            <a:r>
-              <a:rPr b="1">
-                <a:solidFill>
-                  <a:srgbClr val="1E3A8A"/>
-                </a:solidFill>
-              </a:rPr>
-              <a:t>Fundamento: </a:t>
-            </a:r>
-            <a:r>
-              <a:rPr>
-                <a:solidFill>
-                  <a:srgbClr val="334155"/>
-                </a:solidFill>
-              </a:rPr>
-              <a:t>Arquitectura Cache-First: el reproductor nunca hace streaming directo. Descarga preventivamente los videos a disco local y verifica SHA-256. Ante caída de red, reproduce localmente y expone un panel web en la intranet para control manual de emergencia.</a:t>
-            </a:r>
-          </a:p>
-        </p:txBody>
-      </p:sp>
-      <p:sp>
-        <p:nvSpPr>
-          <p:cNvPr id="8" name="Rectangle 7"/>
-          <p:cNvSpPr/>
-          <p:nvPr/>
-        </p:nvSpPr>
-        <p:spPr>
-          <a:xfrm>
-            <a:off x="6263640" y="1691640"/>
-            <a:ext cx="5120640" cy="73152"/>
-          </a:xfrm>
-          <a:prstGeom prst="rect">
-            <a:avLst/>
-          </a:prstGeom>
-          <a:solidFill>
-            <a:srgbClr val="0D9488"/>
-          </a:solidFill>
-          <a:ln>
-            <a:noFill/>
-          </a:ln>
-        </p:spPr>
-        <p:style>
-          <a:lnRef idx="1">
-            <a:schemeClr val="accent1"/>
-          </a:lnRef>
-          <a:fillRef idx="3">
-            <a:schemeClr val="accent1"/>
-          </a:fillRef>
-          <a:effectRef idx="2">
-            <a:schemeClr val="accent1"/>
-          </a:effectRef>
-          <a:fontRef idx="minor">
-            <a:schemeClr val="lt1"/>
-          </a:fontRef>
-        </p:style>
-        <p:txBody>
-          <a:bodyPr rtlCol="0" anchor="ctr"/>
-          <a:lstStyle/>
-          <a:p>
-            <a:pPr algn="ctr"/>
-          </a:p>
-        </p:txBody>
-      </p:sp>
-      <p:sp>
-        <p:nvSpPr>
-          <p:cNvPr id="9" name="Rounded Rectangle 8"/>
-          <p:cNvSpPr/>
-          <p:nvPr/>
-        </p:nvSpPr>
-        <p:spPr>
-          <a:xfrm>
-            <a:off x="731520" y="4023360"/>
-            <a:ext cx="5212080" cy="2194560"/>
-          </a:xfrm>
-          <a:prstGeom prst="roundRect">
-            <a:avLst/>
-          </a:prstGeom>
-          <a:solidFill>
-            <a:srgbClr val="F8FAFC"/>
-          </a:solidFill>
-          <a:ln w="12700">
-            <a:solidFill>
-              <a:srgbClr val="E2E8F0"/>
-            </a:solidFill>
-          </a:ln>
-        </p:spPr>
-        <p:style>
-          <a:lnRef idx="1">
-            <a:schemeClr val="accent1"/>
-          </a:lnRef>
-          <a:fillRef idx="3">
-            <a:schemeClr val="accent1"/>
-          </a:fillRef>
-          <a:effectRef idx="2">
-            <a:schemeClr val="accent1"/>
-          </a:effectRef>
-          <a:fontRef idx="minor">
-            <a:schemeClr val="lt1"/>
-          </a:fontRef>
-        </p:style>
-        <p:txBody>
-          <a:bodyPr rtlCol="0" anchor="t" wrap="square" lIns="228600" rIns="228600" tIns="201168" bIns="182880"/>
-          <a:lstStyle/>
-          <a:p>
-            <a:pPr algn="ctr">
-              <a:spcAft>
-                <a:spcPts val="800"/>
-              </a:spcAft>
-              <a:defRPr sz="1500" b="1">
-                <a:solidFill>
-                  <a:srgbClr val="1E3A8A"/>
-                </a:solidFill>
-                <a:latin typeface="Arial"/>
-              </a:defRPr>
-            </a:pPr>
-            <a:r>
-              <a:t>¿Cómo aseguran terminar en 18 semanas?</a:t>
-            </a:r>
-          </a:p>
-          <a:p>
-            <a:pPr>
-              <a:spcAft>
-                <a:spcPts val="500"/>
-              </a:spcAft>
-              <a:defRPr sz="1100">
-                <a:latin typeface="Arial"/>
-              </a:defRPr>
-            </a:pPr>
-            <a:r>
-              <a:rPr b="1">
-                <a:solidFill>
-                  <a:srgbClr val="1E3A8A"/>
-                </a:solidFill>
-              </a:rPr>
-              <a:t>Fundamento: </a:t>
-            </a:r>
-            <a:r>
-              <a:rPr>
-                <a:solidFill>
-                  <a:srgbClr val="334155"/>
-                </a:solidFill>
-              </a:rPr>
-              <a:t>Delimitación estricta del alcance: ACE es distribución y programación (se excluye edición de video). Scrum bisemanal con hito crítico en S10 (core API y DB operativo), dejando semanas finales para pruebas de resiliencia y UAT con Lumina.</a:t>
-            </a:r>
-          </a:p>
-        </p:txBody>
-      </p:sp>
-      <p:sp>
-        <p:nvSpPr>
-          <p:cNvPr id="10" name="Rectangle 9"/>
-          <p:cNvSpPr/>
-          <p:nvPr/>
-        </p:nvSpPr>
-        <p:spPr>
-          <a:xfrm>
-            <a:off x="777240" y="4069080"/>
-            <a:ext cx="5120640" cy="73152"/>
-          </a:xfrm>
-          <a:prstGeom prst="rect">
-            <a:avLst/>
-          </a:prstGeom>
-          <a:solidFill>
-            <a:srgbClr val="D97706"/>
-          </a:solidFill>
-          <a:ln>
-            <a:noFill/>
-          </a:ln>
-        </p:spPr>
-        <p:style>
-          <a:lnRef idx="1">
-            <a:schemeClr val="accent1"/>
-          </a:lnRef>
-          <a:fillRef idx="3">
-            <a:schemeClr val="accent1"/>
-          </a:fillRef>
-          <a:effectRef idx="2">
-            <a:schemeClr val="accent1"/>
-          </a:effectRef>
-          <a:fontRef idx="minor">
-            <a:schemeClr val="lt1"/>
-          </a:fontRef>
-        </p:style>
-        <p:txBody>
-          <a:bodyPr rtlCol="0" anchor="ctr"/>
-          <a:lstStyle/>
-          <a:p>
-            <a:pPr algn="ctr"/>
-          </a:p>
-        </p:txBody>
-      </p:sp>
-      <p:sp>
-        <p:nvSpPr>
-          <p:cNvPr id="11" name="Rounded Rectangle 10"/>
-          <p:cNvSpPr/>
-          <p:nvPr/>
-        </p:nvSpPr>
-        <p:spPr>
-          <a:xfrm>
-            <a:off x="6217920" y="4023360"/>
-            <a:ext cx="5212080" cy="2194560"/>
-          </a:xfrm>
-          <a:prstGeom prst="roundRect">
-            <a:avLst/>
-          </a:prstGeom>
-          <a:solidFill>
-            <a:srgbClr val="F8FAFC"/>
-          </a:solidFill>
-          <a:ln w="12700">
-            <a:solidFill>
-              <a:srgbClr val="E2E8F0"/>
-            </a:solidFill>
-          </a:ln>
-        </p:spPr>
-        <p:style>
-          <a:lnRef idx="1">
-            <a:schemeClr val="accent1"/>
-          </a:lnRef>
-          <a:fillRef idx="3">
-            <a:schemeClr val="accent1"/>
-          </a:fillRef>
-          <a:effectRef idx="2">
-            <a:schemeClr val="accent1"/>
-          </a:effectRef>
-          <a:fontRef idx="minor">
-            <a:schemeClr val="lt1"/>
-          </a:fontRef>
-        </p:style>
-        <p:txBody>
-          <a:bodyPr rtlCol="0" anchor="t" wrap="square" lIns="228600" rIns="228600" tIns="201168" bIns="182880"/>
-          <a:lstStyle/>
-          <a:p>
-            <a:pPr algn="ctr">
-              <a:spcAft>
-                <a:spcPts val="800"/>
-              </a:spcAft>
-              <a:defRPr sz="1500" b="1">
-                <a:solidFill>
-                  <a:srgbClr val="1E3A8A"/>
-                </a:solidFill>
-                <a:latin typeface="Arial"/>
-              </a:defRPr>
-            </a:pPr>
-            <a:r>
-              <a:t>¿Cómo garantizan aporte equitativo?</a:t>
-            </a:r>
-          </a:p>
-          <a:p>
-            <a:pPr>
-              <a:spcAft>
-                <a:spcPts val="500"/>
-              </a:spcAft>
-              <a:defRPr sz="1100">
-                <a:latin typeface="Arial"/>
-              </a:defRPr>
-            </a:pPr>
-            <a:r>
-              <a:t>Fundamento: Distribución por dominios técnicos complementarios y corresponsabilidad en persistencia (MariaDB): Tomás (Arquitectura, Backend y BD), Matías (Gestión Ágil, Vinculación con Cliente y BD) y Paulo (Frontend, UI/UX y Documentación Técnica). Trazabilidad auditable mediante Pull Requests cruzados en GitHub.</a:t>
-            </a:r>
-          </a:p>
-        </p:txBody>
-      </p:sp>
-      <p:sp>
-        <p:nvSpPr>
-          <p:cNvPr id="12" name="Rectangle 11"/>
-          <p:cNvSpPr/>
-          <p:nvPr/>
-        </p:nvSpPr>
-        <p:spPr>
-          <a:xfrm>
-            <a:off x="6263640" y="4069080"/>
-            <a:ext cx="5120640" cy="73152"/>
-          </a:xfrm>
-          <a:prstGeom prst="rect">
-            <a:avLst/>
-          </a:prstGeom>
-          <a:solidFill>
-            <a:srgbClr val="1E3A8A"/>
-          </a:solidFill>
-          <a:ln>
-            <a:noFill/>
-          </a:ln>
-        </p:spPr>
-        <p:style>
-          <a:lnRef idx="1">
-            <a:schemeClr val="accent1"/>
-          </a:lnRef>
-          <a:fillRef idx="3">
-            <a:schemeClr val="accent1"/>
-          </a:fillRef>
-          <a:effectRef idx="2">
-            <a:schemeClr val="accent1"/>
-          </a:effectRef>
-          <a:fontRef idx="minor">
-            <a:schemeClr val="lt1"/>
-          </a:fontRef>
-        </p:style>
-        <p:txBody>
-          <a:bodyPr rtlCol="0" anchor="ctr"/>
-          <a:lstStyle/>
-          <a:p>
-            <a:pPr algn="ctr"/>
+                <a:solidFill>
+                  <a:srgbClr val="6E7882"/>
+                </a:solidFill>
+              </a:defRPr>
+            </a:pPr>
+            <a:br/>
+            <a:r>
+              <a:t>Pegue o inserte aquí la captura de pantalla del prototipo de alta fidelidad diseñado en Figma.</a:t>
+            </a:r>
+            <a:br/>
+            <a:r>
+              <a:t>(Panel Web Reactivo Blade • Parrilla de Programación • Telemetría NUC en Vivo)</a:t>
+            </a:r>
           </a:p>
         </p:txBody>
       </p:sp>

</xml_diff>